<commit_message>
Switch sanctuary model from rescue/adoption to paid retirement boarding
The sanctuary no longer adopts/rescues horses; instead it's a paid
retirement and wellness boarding facility where owners keep their horse
and pay ฿15,000/month plus vet fees (billed directly to the owner, not
a Foundation cost). This flips the sanctuary from a donation-dependent
deficit operation to cash-flow positive from Year 1. Boarding clients
are also identified as the primary target market for the 32-rai plots.

Sanctuary capital drops from ~56.4M to ~54.7M (no rescue-intake/rehab
cost line, replaced with a modest onboarding/fit-out cost). Updated the
business plan, the artifact, and the PowerPoint deck to match throughout
(mission, products/services, market analysis, operations, marketing,
legal checklist, financials, risks, and timeline).

Co-Authored-By: Claude Sonnet 5 <noreply@anthropic.com>
Claude-Session: https://claude.ai/code/session_01T2AH8DfmywYakYgEQMQoZc
</commit_message>
<xml_diff>
--- a/business-plan/presentation/Angel_Arms_Sanctuary_Plan.pptx
+++ b/business-plan/presentation/Angel_Arms_Sanctuary_Plan.pptx
@@ -195,34 +195,34 @@
                     <c:v>Covered therapy arena</c:v>
                   </c:pt>
                   <c:pt idx="3">
-                    <c:v>Quarantine &amp; vet clinic</c:v>
+                    <c:v>Quarantine &amp; vet clinic (building)</c:v>
                   </c:pt>
                   <c:pt idx="4">
                     <c:v>Site prep &amp; infrastructure</c:v>
                   </c:pt>
                   <c:pt idx="5">
-                    <c:v>Initial horse intake (15 horses)</c:v>
+                    <c:v>Admin/reception office</c:v>
                   </c:pt>
                   <c:pt idx="6">
-                    <c:v>Admin/reception office</c:v>
+                    <c:v>Equipment &amp; vehicles</c:v>
                   </c:pt>
                   <c:pt idx="7">
-                    <c:v>Equipment &amp; vehicles</c:v>
+                    <c:v>Fencing</c:v>
                   </c:pt>
                   <c:pt idx="8">
-                    <c:v>Fencing</c:v>
+                    <c:v>Contingency + legal</c:v>
                   </c:pt>
                   <c:pt idx="9">
-                    <c:v>Contingency + legal</c:v>
+                    <c:v>Pasture establishment</c:v>
                   </c:pt>
                   <c:pt idx="10">
-                    <c:v>Pasture establishment</c:v>
+                    <c:v>Working capital reserve</c:v>
                   </c:pt>
                   <c:pt idx="11">
-                    <c:v>Working capital reserve</c:v>
+                    <c:v>Staff housing</c:v>
                   </c:pt>
                   <c:pt idx="12">
-                    <c:v>Staff housing</c:v>
+                    <c:v>Initial stable fit-out &amp; onboarding</c:v>
                   </c:pt>
                 </c:lvl>
               </c:multiLvlStrCache>
@@ -250,28 +250,28 @@
                   <c:v>2500000</c:v>
                 </c:pt>
                 <c:pt idx="5">
-                  <c:v>2200000</c:v>
+                  <c:v>1800000</c:v>
                 </c:pt>
                 <c:pt idx="6">
-                  <c:v>1800000</c:v>
+                  <c:v>1500000</c:v>
                 </c:pt>
                 <c:pt idx="7">
                   <c:v>1500000</c:v>
                 </c:pt>
                 <c:pt idx="8">
-                  <c:v>1500000</c:v>
+                  <c:v>1200000</c:v>
                 </c:pt>
                 <c:pt idx="9">
-                  <c:v>1200000</c:v>
+                  <c:v>900000</c:v>
                 </c:pt>
                 <c:pt idx="10">
-                  <c:v>900000</c:v>
+                  <c:v>800000</c:v>
                 </c:pt>
                 <c:pt idx="11">
-                  <c:v>800000</c:v>
+                  <c:v>600000</c:v>
                 </c:pt>
                 <c:pt idx="12">
-                  <c:v>600000</c:v>
+                  <c:v>500000</c:v>
                 </c:pt>
               </c:numCache>
             </c:numRef>
@@ -518,19 +518,19 @@
                 <c:formatCode>General</c:formatCode>
                 <c:ptCount val="5"/>
                 <c:pt idx="0">
-                  <c:v>-2322400</c:v>
+                  <c:v>320000</c:v>
                 </c:pt>
                 <c:pt idx="1">
-                  <c:v>-2183520</c:v>
+                  <c:v>1692000</c:v>
                 </c:pt>
                 <c:pt idx="2">
-                  <c:v>-2114480</c:v>
+                  <c:v>2818000</c:v>
                 </c:pt>
                 <c:pt idx="3">
-                  <c:v>-1825120</c:v>
+                  <c:v>3812000</c:v>
                 </c:pt>
                 <c:pt idx="4">
-                  <c:v>-1695600</c:v>
+                  <c:v>4470000</c:v>
                 </c:pt>
               </c:numCache>
             </c:numRef>
@@ -758,19 +758,19 @@
                 <c:formatCode>General</c:formatCode>
                 <c:ptCount val="5"/>
                 <c:pt idx="0">
-                  <c:v>-2300600</c:v>
+                  <c:v>341800</c:v>
                 </c:pt>
                 <c:pt idx="1">
-                  <c:v>-1700280</c:v>
+                  <c:v>2175240</c:v>
                 </c:pt>
                 <c:pt idx="2">
-                  <c:v>-1211480</c:v>
+                  <c:v>3721000</c:v>
                 </c:pt>
                 <c:pt idx="3">
-                  <c:v>-734720</c:v>
+                  <c:v>4902400</c:v>
                 </c:pt>
                 <c:pt idx="4">
-                  <c:v>-564240</c:v>
+                  <c:v>5601360</c:v>
                 </c:pt>
               </c:numCache>
             </c:numRef>
@@ -851,6 +851,7 @@
         <c:axId val="2094734552"/>
         <c:scaling>
           <c:orientation val="minMax"/>
+          <c:min val="0"/>
         </c:scaling>
         <c:delete val="0"/>
         <c:axPos val="l"/>
@@ -3220,7 +3221,7 @@
                 <a:ea typeface="Calibri" pitchFamily="34" charset="-122"/>
                 <a:cs typeface="Calibri" pitchFamily="34" charset="-120"/>
               </a:rPr>
-              <a:t>A rescue and equine-therapy sanctuary on 10 rai in Nakhon Nayok — anchoring a 32-rai equestrian community sold off-plan in partnership with the land owner.</a:t>
+              <a:t>A paid horse retirement &amp; wellness boarding facility with an equine-therapy program on 10 rai in Nakhon Nayok — anchoring a 32-rai equestrian community sold off-plan in partnership with the land owner.</a:t>
             </a:r>
             <a:endParaRPr lang="en-US" sz="1600" dirty="0"/>
           </a:p>
@@ -3422,7 +3423,7 @@
                 <a:ea typeface="Cambria" pitchFamily="34" charset="-122"/>
                 <a:cs typeface="Cambria" pitchFamily="34" charset="-120"/>
               </a:rPr>
-              <a:t>~฿56–70M</a:t>
+              <a:t>~฿54–69M</a:t>
             </a:r>
             <a:endParaRPr lang="en-US" sz="2200" dirty="0"/>
           </a:p>
@@ -3484,7 +3485,7 @@
                 <a:ea typeface="Calibri" pitchFamily="34" charset="-122"/>
                 <a:cs typeface="Calibri" pitchFamily="34" charset="-120"/>
               </a:rPr>
-              <a:t>SANCTUARY BY YEAR 5</a:t>
+              <a:t>BOARDING FEE</a:t>
             </a:r>
             <a:endParaRPr lang="en-US" sz="950" dirty="0"/>
           </a:p>
@@ -3523,7 +3524,7 @@
                 <a:ea typeface="Cambria" pitchFamily="34" charset="-122"/>
                 <a:cs typeface="Cambria" pitchFamily="34" charset="-120"/>
               </a:rPr>
-              <a:t>35 horses</a:t>
+              <a:t>฿15,000/mo/horse</a:t>
             </a:r>
             <a:endParaRPr lang="en-US" sz="2200" dirty="0"/>
           </a:p>
@@ -3901,7 +3902,7 @@
                 <a:ea typeface="Cambria" pitchFamily="34" charset="-122"/>
                 <a:cs typeface="Cambria" pitchFamily="34" charset="-120"/>
               </a:rPr>
-              <a:t>฿56.4M</a:t>
+              <a:t>฿54.7M</a:t>
             </a:r>
             <a:endParaRPr lang="en-US" sz="2200" dirty="0"/>
           </a:p>
@@ -4086,7 +4087,7 @@
                 <a:ea typeface="Calibri" pitchFamily="34" charset="-122"/>
                 <a:cs typeface="Calibri" pitchFamily="34" charset="-120"/>
               </a:rPr>
-              <a:t>OF WHICH IS CONSTRUCTION</a:t>
+              <a:t>OF WHICH IS CONSTRUCTION/FIT-OUT</a:t>
             </a:r>
             <a:endParaRPr lang="en-US" sz="950" dirty="0"/>
           </a:p>
@@ -4125,7 +4126,7 @@
                 <a:ea typeface="Cambria" pitchFamily="34" charset="-122"/>
                 <a:cs typeface="Cambria" pitchFamily="34" charset="-120"/>
               </a:rPr>
-              <a:t>฿33.4M</a:t>
+              <a:t>฿31.7M</a:t>
             </a:r>
             <a:endParaRPr lang="en-US" sz="2200" dirty="0"/>
           </a:p>
@@ -5515,7 +5516,7 @@
                 <a:ea typeface="Cambria" pitchFamily="34" charset="-122"/>
                 <a:cs typeface="Cambria" pitchFamily="34" charset="-120"/>
               </a:rPr>
-              <a:t>Post-launch outlook — a normal nonprofit deficit, narrowing</a:t>
+              <a:t>Post-launch outlook — positive from Year 1</a:t>
             </a:r>
             <a:endParaRPr lang="en-US" sz="3000" dirty="0"/>
           </a:p>
@@ -5604,7 +5605,7 @@
                 <a:ea typeface="Calibri" pitchFamily="34" charset="-122"/>
                 <a:cs typeface="Calibri" pitchFamily="34" charset="-120"/>
               </a:rPr>
-              <a:t>YEAR 1 COMBINED DEFICIT</a:t>
+              <a:t>YEAR 1 COMBINED NET</a:t>
             </a:r>
             <a:endParaRPr lang="en-US" sz="950" dirty="0"/>
           </a:p>
@@ -5637,13 +5638,13 @@
             <a:r>
               <a:rPr lang="en-US" sz="2200" b="1" dirty="0">
                 <a:solidFill>
-                  <a:srgbClr val="C24A78"/>
+                  <a:srgbClr val="2F6B45"/>
                 </a:solidFill>
                 <a:latin typeface="Cambria" pitchFamily="34" charset="0"/>
                 <a:ea typeface="Cambria" pitchFamily="34" charset="-122"/>
                 <a:cs typeface="Cambria" pitchFamily="34" charset="-120"/>
               </a:rPr>
-              <a:t>(฿2.30M)</a:t>
+              <a:t>+฿342k</a:t>
             </a:r>
             <a:endParaRPr lang="en-US" sz="2200" dirty="0"/>
           </a:p>
@@ -5716,7 +5717,7 @@
                 <a:ea typeface="Calibri" pitchFamily="34" charset="-122"/>
                 <a:cs typeface="Calibri" pitchFamily="34" charset="-120"/>
               </a:rPr>
-              <a:t>YEAR 5 COMBINED DEFICIT</a:t>
+              <a:t>YEAR 5 COMBINED NET</a:t>
             </a:r>
             <a:endParaRPr lang="en-US" sz="950" dirty="0"/>
           </a:p>
@@ -5749,13 +5750,13 @@
             <a:r>
               <a:rPr lang="en-US" sz="2200" b="1" dirty="0">
                 <a:solidFill>
-                  <a:srgbClr val="8B5A2B"/>
+                  <a:srgbClr val="2F6B45"/>
                 </a:solidFill>
                 <a:latin typeface="Cambria" pitchFamily="34" charset="0"/>
                 <a:ea typeface="Cambria" pitchFamily="34" charset="-122"/>
                 <a:cs typeface="Cambria" pitchFamily="34" charset="-120"/>
               </a:rPr>
-              <a:t>(฿0.56M)</a:t>
+              <a:t>+฿5.60M</a:t>
             </a:r>
             <a:endParaRPr lang="en-US" sz="2200" dirty="0"/>
           </a:p>
@@ -5816,7 +5817,7 @@
                 <a:ea typeface="Calibri" pitchFamily="34" charset="-122"/>
                 <a:cs typeface="Calibri" pitchFamily="34" charset="-120"/>
               </a:rPr>
-              <a:t>Budget for ongoing fundraising of ~฿1.5–2.3M/year — normal for a rescue/therapy nonprofit.</a:t>
+              <a:t>Boarding fees make this a real paying business — donations and grants are upside, not the lifeline.</a:t>
             </a:r>
             <a:endParaRPr lang="en-US" sz="1150" dirty="0"/>
           </a:p>
@@ -6078,7 +6079,7 @@
                 <a:ea typeface="Cambria" pitchFamily="34" charset="-122"/>
                 <a:cs typeface="Cambria" pitchFamily="34" charset="-120"/>
               </a:rPr>
-              <a:t>Plot sales lag the owner's milestones</a:t>
+              <a:t>Boarding occupancy below the 15→35 plan</a:t>
             </a:r>
             <a:endParaRPr lang="en-US" sz="1300" dirty="0"/>
           </a:p>
@@ -6120,7 +6121,7 @@
                 <a:ea typeface="Calibri" pitchFamily="34" charset="-122"/>
                 <a:cs typeface="Calibri" pitchFamily="34" charset="-120"/>
               </a:rPr>
-              <a:t>Explicit shortfall terms in the partnership contract</a:t>
+              <a:t>Price against the retirement-care gap; costs scale with horse count</a:t>
             </a:r>
             <a:endParaRPr lang="en-US" sz="1050" dirty="0"/>
           </a:p>
@@ -6233,7 +6234,7 @@
                 <a:ea typeface="Cambria" pitchFamily="34" charset="-122"/>
                 <a:cs typeface="Cambria" pitchFamily="34" charset="-120"/>
               </a:rPr>
-              <a:t>Infrastructure fronted before deposits arrive</a:t>
+              <a:t>Plot sales lag the owner's milestones</a:t>
             </a:r>
             <a:endParaRPr lang="en-US" sz="1300" dirty="0"/>
           </a:p>
@@ -6275,7 +6276,7 @@
                 <a:ea typeface="Calibri" pitchFamily="34" charset="-122"/>
                 <a:cs typeface="Calibri" pitchFamily="34" charset="-120"/>
               </a:rPr>
-              <a:t>Sequence roads/utilities first; phase shared amenities</a:t>
+              <a:t>Explicit shortfall terms in the partnership contract</a:t>
             </a:r>
             <a:endParaRPr lang="en-US" sz="1050" dirty="0"/>
           </a:p>
@@ -6388,7 +6389,7 @@
                 <a:ea typeface="Cambria" pitchFamily="34" charset="-122"/>
                 <a:cs typeface="Cambria" pitchFamily="34" charset="-120"/>
               </a:rPr>
-              <a:t>SBT / resale tax worse than estimated</a:t>
+              <a:t>Infrastructure fronted before deposits arrive</a:t>
             </a:r>
             <a:endParaRPr lang="en-US" sz="1300" dirty="0"/>
           </a:p>
@@ -6430,7 +6431,7 @@
                 <a:ea typeface="Calibri" pitchFamily="34" charset="-122"/>
                 <a:cs typeface="Calibri" pitchFamily="34" charset="-120"/>
               </a:rPr>
-              <a:t>Confirm seller-of-record status with an accountant</a:t>
+              <a:t>Sequence roads/utilities first; phase shared amenities</a:t>
             </a:r>
             <a:endParaRPr lang="en-US" sz="1050" dirty="0"/>
           </a:p>
@@ -6543,7 +6544,7 @@
                 <a:ea typeface="Cambria" pitchFamily="34" charset="-122"/>
                 <a:cs typeface="Cambria" pitchFamily="34" charset="-120"/>
               </a:rPr>
-              <a:t>Sanctuary deficit larger than projected</a:t>
+              <a:t>SBT / resale tax worse than estimated</a:t>
             </a:r>
             <a:endParaRPr lang="en-US" sz="1300" dirty="0"/>
           </a:p>
@@ -6585,7 +6586,7 @@
                 <a:ea typeface="Calibri" pitchFamily="34" charset="-122"/>
                 <a:cs typeface="Calibri" pitchFamily="34" charset="-120"/>
               </a:rPr>
-              <a:t>Assess Foundation fundraising capacity up front</a:t>
+              <a:t>Confirm seller-of-record status with an accountant</a:t>
             </a:r>
             <a:endParaRPr lang="en-US" sz="1050" dirty="0"/>
           </a:p>
@@ -6698,7 +6699,7 @@
                 <a:ea typeface="Cambria" pitchFamily="34" charset="-122"/>
                 <a:cs typeface="Cambria" pitchFamily="34" charset="-120"/>
               </a:rPr>
-              <a:t>Flood damage</a:t>
+              <a:t>Vet-fee billing disputes with owners</a:t>
             </a:r>
             <a:endParaRPr lang="en-US" sz="1300" dirty="0"/>
           </a:p>
@@ -6740,7 +6741,7 @@
                 <a:ea typeface="Calibri" pitchFamily="34" charset="-122"/>
                 <a:cs typeface="Calibri" pitchFamily="34" charset="-120"/>
               </a:rPr>
-              <a:t>Confirm flood-elevation data before finalizing placement</a:t>
+              <a:t>Clear billing process in the standard boarding agreement</a:t>
             </a:r>
             <a:endParaRPr lang="en-US" sz="1050" dirty="0"/>
           </a:p>
@@ -6853,7 +6854,7 @@
                 <a:ea typeface="Cambria" pitchFamily="34" charset="-122"/>
                 <a:cs typeface="Cambria" pitchFamily="34" charset="-120"/>
               </a:rPr>
-              <a:t>Land title/subdivision issues</a:t>
+              <a:t>Flood damage</a:t>
             </a:r>
             <a:endParaRPr lang="en-US" sz="1300" dirty="0"/>
           </a:p>
@@ -6895,7 +6896,7 @@
                 <a:ea typeface="Calibri" pitchFamily="34" charset="-122"/>
                 <a:cs typeface="Calibri" pitchFamily="34" charset="-120"/>
               </a:rPr>
-              <a:t>Complete formal legal re-survey before signing</a:t>
+              <a:t>Confirm flood-elevation data before finalizing placement</a:t>
             </a:r>
             <a:endParaRPr lang="en-US" sz="1050" dirty="0"/>
           </a:p>
@@ -7659,7 +7660,7 @@
                 <a:ea typeface="Calibri" pitchFamily="34" charset="-122"/>
                 <a:cs typeface="Calibri" pitchFamily="34" charset="-120"/>
               </a:rPr>
-              <a:t>First rescue horses arrive; therapy specialist hired</a:t>
+              <a:t>First boarding horses move in; therapy specialist hired</a:t>
             </a:r>
             <a:endParaRPr lang="en-US" sz="900" dirty="0"/>
           </a:p>
@@ -7807,7 +7808,7 @@
                 <a:ea typeface="Calibri" pitchFamily="34" charset="-122"/>
                 <a:cs typeface="Calibri" pitchFamily="34" charset="-120"/>
               </a:rPr>
-              <a:t>Plot sales close; residents move in; amenities open</a:t>
+              <a:t>Plot sales close (boarding clients first); residents move in; amenities open</a:t>
             </a:r>
             <a:endParaRPr lang="en-US" sz="900" dirty="0"/>
           </a:p>
@@ -7955,7 +7956,7 @@
                 <a:ea typeface="Calibri" pitchFamily="34" charset="-122"/>
                 <a:cs typeface="Calibri" pitchFamily="34" charset="-120"/>
               </a:rPr>
-              <a:t>Grow horse population &amp; therapy caseload; surplus subsidizes deficit</a:t>
+              <a:t>Grow boarding population toward 35 horses &amp; therapy caseload</a:t>
             </a:r>
             <a:endParaRPr lang="en-US" sz="900" dirty="0"/>
           </a:p>
@@ -8304,7 +8305,7 @@
                 <a:ea typeface="Calibri" pitchFamily="34" charset="-122"/>
                 <a:cs typeface="Calibri" pitchFamily="34" charset="-120"/>
               </a:rPr>
-              <a:t>Commission a formal land re-survey, including the 10/32-rai split</a:t>
+              <a:t>Validate boarding occupancy assumptions (15→35 horses at ฿15,000/mo) against real local demand</a:t>
             </a:r>
             <a:endParaRPr lang="en-US" sz="1400" dirty="0"/>
           </a:p>
@@ -8404,7 +8405,7 @@
                 <a:ea typeface="Calibri" pitchFamily="34" charset="-122"/>
                 <a:cs typeface="Calibri" pitchFamily="34" charset="-120"/>
               </a:rPr>
-              <a:t>Confirm SBT and transfer-fee treatment — and who is the seller of record — with an accountant</a:t>
+              <a:t>Draft the standard boarding service agreement, including vet-fee billing mechanics</a:t>
             </a:r>
             <a:endParaRPr lang="en-US" sz="1400" dirty="0"/>
           </a:p>
@@ -8504,7 +8505,7 @@
                 <a:ea typeface="Calibri" pitchFamily="34" charset="-122"/>
                 <a:cs typeface="Calibri" pitchFamily="34" charset="-120"/>
               </a:rPr>
-              <a:t>Set plot-buyer deposit/installment terms that keep sales pace ahead of the owner's schedule</a:t>
+              <a:t>Commission a formal land re-survey, including the 10/32-rai split</a:t>
             </a:r>
             <a:endParaRPr lang="en-US" sz="1400" dirty="0"/>
           </a:p>
@@ -8604,7 +8605,7 @@
                 <a:ea typeface="Calibri" pitchFamily="34" charset="-122"/>
                 <a:cs typeface="Calibri" pitchFamily="34" charset="-120"/>
               </a:rPr>
-              <a:t>Get flood-elevation data for the floating-villa zone</a:t>
+              <a:t>Confirm SBT and transfer-fee treatment — and who is the seller of record — with an accountant</a:t>
             </a:r>
             <a:endParaRPr lang="en-US" sz="1400" dirty="0"/>
           </a:p>
@@ -9255,7 +9256,7 @@
                 <a:ea typeface="Calibri" pitchFamily="34" charset="-122"/>
                 <a:cs typeface="Calibri" pitchFamily="34" charset="-120"/>
               </a:rPr>
-              <a:t>Owned by The Angel Arms Foundation — an existing foundation. </a:t>
+              <a:t>Owned by The Angel Arms Foundation. A paid retirement/boarding facility — </a:t>
             </a:r>
             <a:pPr indent="0" marL="0">
               <a:lnSpc>
@@ -9272,7 +9273,7 @@
                 <a:ea typeface="Calibri" pitchFamily="34" charset="-122"/>
                 <a:cs typeface="Calibri" pitchFamily="34" charset="-120"/>
               </a:rPr>
-              <a:t>Rescue, rehabilitation, and equine-assisted therapy for special-needs children.</a:t>
+              <a:t>owners keep their horse and pay ฿15,000/month + vet fees for full-service care, plus a children's equine-therapy program.</a:t>
             </a:r>
             <a:endParaRPr lang="en-US" sz="1300" dirty="0"/>
           </a:p>
@@ -9311,7 +9312,7 @@
                 <a:ea typeface="Calibri" pitchFamily="34" charset="-122"/>
                 <a:cs typeface="Calibri" pitchFamily="34" charset="-120"/>
               </a:rPr>
-              <a:t>A mission program, not a profit center — runs on donations, CSR, and grants.</a:t>
+              <a:t>A real paying business, not a donation-dependent rescue — positive from Year 1.</a:t>
             </a:r>
             <a:endParaRPr lang="en-US" sz="1300" dirty="0"/>
           </a:p>
@@ -9412,7 +9413,7 @@
                 <a:ea typeface="Cambria" pitchFamily="34" charset="-122"/>
                 <a:cs typeface="Cambria" pitchFamily="34" charset="-120"/>
               </a:rPr>
-              <a:t>~฿56.4M</a:t>
+              <a:t>~฿54.7M</a:t>
             </a:r>
             <a:endParaRPr lang="en-US" sz="3000" dirty="0"/>
           </a:p>
@@ -9598,7 +9599,7 @@
                 <a:ea typeface="Calibri" pitchFamily="34" charset="-122"/>
                 <a:cs typeface="Calibri" pitchFamily="34" charset="-120"/>
               </a:rPr>
-              <a:t>15–18 plots sold to horse-owning families. The owner keeps the deed and transfers title directly to each buyer, in step with the payment plan.</a:t>
+              <a:t>15–18 plots sold first to boarding clients, then the broader market. The owner keeps the deed and transfers title directly to each buyer, in step with the payment plan.</a:t>
             </a:r>
             <a:endParaRPr lang="en-US" sz="1300" dirty="0"/>
           </a:p>
@@ -10051,7 +10052,7 @@
                 <a:ea typeface="Cambria" pitchFamily="34" charset="-122"/>
                 <a:cs typeface="Cambria" pitchFamily="34" charset="-120"/>
               </a:rPr>
-              <a:t>Rescue &amp; rehabilitate</a:t>
+              <a:t>Retirement &amp; wellness boarding</a:t>
             </a:r>
             <a:endParaRPr lang="en-US" sz="1500" dirty="0"/>
           </a:p>
@@ -10090,7 +10091,7 @@
                 <a:ea typeface="Calibri" pitchFamily="34" charset="-122"/>
                 <a:cs typeface="Calibri" pitchFamily="34" charset="-120"/>
               </a:rPr>
-              <a:t>Lifelong care for retired and injured horses.</a:t>
+              <a:t>Full-service paid care at ฿15,000/month + vet fees — owners keep their horse.</a:t>
             </a:r>
             <a:endParaRPr lang="en-US" sz="1200" dirty="0"/>
           </a:p>
@@ -10334,7 +10335,7 @@
                 <a:ea typeface="Calibri" pitchFamily="34" charset="-122"/>
                 <a:cs typeface="Calibri" pitchFamily="34" charset="-120"/>
               </a:rPr>
-              <a:t>A resident network of horse-owning families that funds itself.</a:t>
+              <a:t>A resident network drawn first from boarding clients, whose land purchase funds itself.</a:t>
             </a:r>
             <a:endParaRPr lang="en-US" sz="1200" dirty="0"/>
           </a:p>
@@ -10791,7 +10792,7 @@
                 <a:ea typeface="Calibri" pitchFamily="34" charset="-122"/>
                 <a:cs typeface="Calibri" pitchFamily="34" charset="-120"/>
               </a:rPr>
-              <a:t>Owns the 10-rai sanctuary and its mission: rescue, therapy, donor &amp; grant relationships. No new charity registration needed.</a:t>
+              <a:t>Owns the 10-rai sanctuary: paid retirement boarding, therapy, donor &amp; grant relationships. No new charity registration needed.</a:t>
             </a:r>
             <a:endParaRPr lang="en-US" sz="1250" dirty="0"/>
           </a:p>
@@ -11241,7 +11242,7 @@
                 <a:ea typeface="Calibri" pitchFamily="34" charset="-122"/>
                 <a:cs typeface="Calibri" pitchFamily="34" charset="-120"/>
               </a:rPr>
-              <a:t>Runs the café, shared glamping/EV/villa, and collects HOA-style fees — its surplus can subsidize the sanctuary's deficit.</a:t>
+              <a:t>Runs the café, shared glamping/EV/villa, and collects HOA-style fees — a growing surplus on top of the sanctuary's own boarding-fee income.</a:t>
             </a:r>
             <a:endParaRPr lang="en-US" sz="1250" dirty="0"/>
           </a:p>
@@ -12509,7 +12510,7 @@
                 <a:ea typeface="Calibri" pitchFamily="34" charset="-122"/>
                 <a:cs typeface="Calibri" pitchFamily="34" charset="-120"/>
               </a:rPr>
-              <a:t>Intake assessment and rehab</a:t>
+              <a:t>New-arrival checks &amp; settling-in</a:t>
             </a:r>
             <a:endParaRPr lang="en-US" sz="1050" dirty="0"/>
           </a:p>
@@ -12797,7 +12798,7 @@
                 <a:ea typeface="Calibri" pitchFamily="34" charset="-122"/>
                 <a:cs typeface="Calibri" pitchFamily="34" charset="-120"/>
               </a:rPr>
-              <a:t>9 zones: grazing &amp; rehab cells</a:t>
+              <a:t>9 zones: grazing &amp; turnout cells</a:t>
             </a:r>
             <a:endParaRPr lang="en-US" sz="1050" dirty="0"/>
           </a:p>
@@ -13423,7 +13424,7 @@
                 <a:ea typeface="Cambria" pitchFamily="34" charset="-122"/>
                 <a:cs typeface="Cambria" pitchFamily="34" charset="-120"/>
               </a:rPr>
-              <a:t>Mission programs vs. community amenities</a:t>
+              <a:t>A paid boarding business + a mission program</a:t>
             </a:r>
             <a:endParaRPr lang="en-US" sz="3000" dirty="0"/>
           </a:p>
@@ -13462,7 +13463,7 @@
                 <a:ea typeface="Calibri" pitchFamily="34" charset="-122"/>
                 <a:cs typeface="Calibri" pitchFamily="34" charset="-120"/>
               </a:rPr>
-              <a:t>SANCTUARY · FOUNDATION, MISSION-FUNDED</a:t>
+              <a:t>SANCTUARY · FOUNDATION</a:t>
             </a:r>
             <a:endParaRPr lang="en-US" sz="1100" dirty="0"/>
           </a:p>
@@ -13580,7 +13581,7 @@
                           <a:ea typeface="Calibri" pitchFamily="34" charset="-122"/>
                           <a:cs typeface="Calibri" pitchFamily="34" charset="-120"/>
                         </a:rPr>
-                        <a:t>Notes</a:t>
+                        <a:t>Price</a:t>
                       </a:r>
                       <a:endParaRPr lang="en-US" sz="1200" dirty="0">
                         <a:latin typeface="Calibri" charset="0"/>
@@ -13629,6 +13630,138 @@
                     <a:solidFill>
                       <a:srgbClr val="2F6B45"/>
                     </a:solidFill>
+                  </a:tcPr>
+                </a:tc>
+              </a:tr>
+              <a:tr h="457200">
+                <a:tc>
+                  <a:txBody>
+                    <a:bodyPr/>
+                    <a:lstStyle/>
+                    <a:p>
+                      <a:pPr indent="0" marL="0">
+                        <a:buNone/>
+                      </a:pPr>
+                      <a:r>
+                        <a:rPr lang="en-US" sz="1200" b="1" dirty="0">
+                          <a:solidFill>
+                            <a:srgbClr val="22281F"/>
+                          </a:solidFill>
+                          <a:latin typeface="Calibri" pitchFamily="34" charset="0"/>
+                          <a:ea typeface="Calibri" pitchFamily="34" charset="-122"/>
+                          <a:cs typeface="Calibri" pitchFamily="34" charset="-120"/>
+                        </a:rPr>
+                        <a:t>Retirement/wellness boarding</a:t>
+                      </a:r>
+                      <a:endParaRPr lang="en-US" sz="1200" dirty="0">
+                        <a:latin typeface="Calibri" charset="0"/>
+                        <a:ea typeface="Calibri" charset="0"/>
+                        <a:cs typeface="Calibri" charset="0"/>
+                      </a:endParaRPr>
+                    </a:p>
+                  </a:txBody>
+                  <a:tcPr marL="91440" marR="91440" marT="45720" marB="45720" anchor="ctr">
+                    <a:lnL w="9525" cap="flat" cmpd="sng" algn="ctr">
+                      <a:solidFill>
+                        <a:srgbClr val="E4DFCF"/>
+                      </a:solidFill>
+                      <a:prstDash val="solid"/>
+                      <a:round/>
+                      <a:headEnd type="none" w="med" len="med"/>
+                      <a:tailEnd type="none" w="med" len="med"/>
+                    </a:lnL>
+                    <a:lnR w="9525" cap="flat" cmpd="sng" algn="ctr">
+                      <a:solidFill>
+                        <a:srgbClr val="E4DFCF"/>
+                      </a:solidFill>
+                      <a:prstDash val="solid"/>
+                      <a:round/>
+                      <a:headEnd type="none" w="med" len="med"/>
+                      <a:tailEnd type="none" w="med" len="med"/>
+                    </a:lnR>
+                    <a:lnT w="9525" cap="flat" cmpd="sng" algn="ctr">
+                      <a:solidFill>
+                        <a:srgbClr val="E4DFCF"/>
+                      </a:solidFill>
+                      <a:prstDash val="solid"/>
+                      <a:round/>
+                      <a:headEnd type="none" w="med" len="med"/>
+                      <a:tailEnd type="none" w="med" len="med"/>
+                    </a:lnT>
+                    <a:lnB w="9525" cap="flat" cmpd="sng" algn="ctr">
+                      <a:solidFill>
+                        <a:srgbClr val="E4DFCF"/>
+                      </a:solidFill>
+                      <a:prstDash val="solid"/>
+                      <a:round/>
+                      <a:headEnd type="none" w="med" len="med"/>
+                      <a:tailEnd type="none" w="med" len="med"/>
+                    </a:lnB>
+                  </a:tcPr>
+                </a:tc>
+                <a:tc>
+                  <a:txBody>
+                    <a:bodyPr/>
+                    <a:lstStyle/>
+                    <a:p>
+                      <a:pPr indent="0" marL="0">
+                        <a:buNone/>
+                      </a:pPr>
+                      <a:r>
+                        <a:rPr lang="en-US" sz="1200" b="1" dirty="0">
+                          <a:solidFill>
+                            <a:srgbClr val="22281F"/>
+                          </a:solidFill>
+                          <a:latin typeface="Calibri" pitchFamily="34" charset="0"/>
+                          <a:ea typeface="Calibri" pitchFamily="34" charset="-122"/>
+                          <a:cs typeface="Calibri" pitchFamily="34" charset="-120"/>
+                        </a:rPr>
+                        <a:t>฿15,000/mo + vet fees</a:t>
+                      </a:r>
+                      <a:endParaRPr lang="en-US" sz="1200" dirty="0">
+                        <a:latin typeface="Calibri" charset="0"/>
+                        <a:ea typeface="Calibri" charset="0"/>
+                        <a:cs typeface="Calibri" charset="0"/>
+                      </a:endParaRPr>
+                    </a:p>
+                  </a:txBody>
+                  <a:tcPr marL="91440" marR="91440" marT="45720" marB="45720" anchor="ctr">
+                    <a:lnL w="9525" cap="flat" cmpd="sng" algn="ctr">
+                      <a:solidFill>
+                        <a:srgbClr val="E4DFCF"/>
+                      </a:solidFill>
+                      <a:prstDash val="solid"/>
+                      <a:round/>
+                      <a:headEnd type="none" w="med" len="med"/>
+                      <a:tailEnd type="none" w="med" len="med"/>
+                    </a:lnL>
+                    <a:lnR w="9525" cap="flat" cmpd="sng" algn="ctr">
+                      <a:solidFill>
+                        <a:srgbClr val="E4DFCF"/>
+                      </a:solidFill>
+                      <a:prstDash val="solid"/>
+                      <a:round/>
+                      <a:headEnd type="none" w="med" len="med"/>
+                      <a:tailEnd type="none" w="med" len="med"/>
+                    </a:lnR>
+                    <a:lnT w="9525" cap="flat" cmpd="sng" algn="ctr">
+                      <a:solidFill>
+                        <a:srgbClr val="E4DFCF"/>
+                      </a:solidFill>
+                      <a:prstDash val="solid"/>
+                      <a:round/>
+                      <a:headEnd type="none" w="med" len="med"/>
+                      <a:tailEnd type="none" w="med" len="med"/>
+                    </a:lnT>
+                    <a:lnB w="9525" cap="flat" cmpd="sng" algn="ctr">
+                      <a:solidFill>
+                        <a:srgbClr val="E4DFCF"/>
+                      </a:solidFill>
+                      <a:prstDash val="solid"/>
+                      <a:round/>
+                      <a:headEnd type="none" w="med" len="med"/>
+                      <a:tailEnd type="none" w="med" len="med"/>
+                    </a:lnB>
                   </a:tcPr>
                 </a:tc>
               </a:tr>
@@ -14028,138 +14161,6 @@
                   </a:tcPr>
                 </a:tc>
               </a:tr>
-              <a:tr h="457200">
-                <a:tc>
-                  <a:txBody>
-                    <a:bodyPr/>
-                    <a:lstStyle/>
-                    <a:p>
-                      <a:pPr indent="0" marL="0">
-                        <a:buNone/>
-                      </a:pPr>
-                      <a:r>
-                        <a:rPr lang="en-US" sz="1200" dirty="0">
-                          <a:solidFill>
-                            <a:srgbClr val="22281F"/>
-                          </a:solidFill>
-                          <a:latin typeface="Calibri" pitchFamily="34" charset="0"/>
-                          <a:ea typeface="Calibri" pitchFamily="34" charset="-122"/>
-                          <a:cs typeface="Calibri" pitchFamily="34" charset="-120"/>
-                        </a:rPr>
-                        <a:t>Horse sponsorship/adoption</a:t>
-                      </a:r>
-                      <a:endParaRPr lang="en-US" sz="1200" dirty="0">
-                        <a:latin typeface="Calibri" charset="0"/>
-                        <a:ea typeface="Calibri" charset="0"/>
-                        <a:cs typeface="Calibri" charset="0"/>
-                      </a:endParaRPr>
-                    </a:p>
-                  </a:txBody>
-                  <a:tcPr marL="91440" marR="91440" marT="45720" marB="45720" anchor="ctr">
-                    <a:lnL w="9525" cap="flat" cmpd="sng" algn="ctr">
-                      <a:solidFill>
-                        <a:srgbClr val="E4DFCF"/>
-                      </a:solidFill>
-                      <a:prstDash val="solid"/>
-                      <a:round/>
-                      <a:headEnd type="none" w="med" len="med"/>
-                      <a:tailEnd type="none" w="med" len="med"/>
-                    </a:lnL>
-                    <a:lnR w="9525" cap="flat" cmpd="sng" algn="ctr">
-                      <a:solidFill>
-                        <a:srgbClr val="E4DFCF"/>
-                      </a:solidFill>
-                      <a:prstDash val="solid"/>
-                      <a:round/>
-                      <a:headEnd type="none" w="med" len="med"/>
-                      <a:tailEnd type="none" w="med" len="med"/>
-                    </a:lnR>
-                    <a:lnT w="9525" cap="flat" cmpd="sng" algn="ctr">
-                      <a:solidFill>
-                        <a:srgbClr val="E4DFCF"/>
-                      </a:solidFill>
-                      <a:prstDash val="solid"/>
-                      <a:round/>
-                      <a:headEnd type="none" w="med" len="med"/>
-                      <a:tailEnd type="none" w="med" len="med"/>
-                    </a:lnT>
-                    <a:lnB w="9525" cap="flat" cmpd="sng" algn="ctr">
-                      <a:solidFill>
-                        <a:srgbClr val="E4DFCF"/>
-                      </a:solidFill>
-                      <a:prstDash val="solid"/>
-                      <a:round/>
-                      <a:headEnd type="none" w="med" len="med"/>
-                      <a:tailEnd type="none" w="med" len="med"/>
-                    </a:lnB>
-                  </a:tcPr>
-                </a:tc>
-                <a:tc>
-                  <a:txBody>
-                    <a:bodyPr/>
-                    <a:lstStyle/>
-                    <a:p>
-                      <a:pPr indent="0" marL="0">
-                        <a:buNone/>
-                      </a:pPr>
-                      <a:r>
-                        <a:rPr lang="en-US" sz="1200" dirty="0">
-                          <a:solidFill>
-                            <a:srgbClr val="22281F"/>
-                          </a:solidFill>
-                          <a:latin typeface="Calibri" pitchFamily="34" charset="0"/>
-                          <a:ea typeface="Calibri" pitchFamily="34" charset="-122"/>
-                          <a:cs typeface="Calibri" pitchFamily="34" charset="-120"/>
-                        </a:rPr>
-                        <a:t>฿500–2,000/mo</a:t>
-                      </a:r>
-                      <a:endParaRPr lang="en-US" sz="1200" dirty="0">
-                        <a:latin typeface="Calibri" charset="0"/>
-                        <a:ea typeface="Calibri" charset="0"/>
-                        <a:cs typeface="Calibri" charset="0"/>
-                      </a:endParaRPr>
-                    </a:p>
-                  </a:txBody>
-                  <a:tcPr marL="91440" marR="91440" marT="45720" marB="45720" anchor="ctr">
-                    <a:lnL w="9525" cap="flat" cmpd="sng" algn="ctr">
-                      <a:solidFill>
-                        <a:srgbClr val="E4DFCF"/>
-                      </a:solidFill>
-                      <a:prstDash val="solid"/>
-                      <a:round/>
-                      <a:headEnd type="none" w="med" len="med"/>
-                      <a:tailEnd type="none" w="med" len="med"/>
-                    </a:lnL>
-                    <a:lnR w="9525" cap="flat" cmpd="sng" algn="ctr">
-                      <a:solidFill>
-                        <a:srgbClr val="E4DFCF"/>
-                      </a:solidFill>
-                      <a:prstDash val="solid"/>
-                      <a:round/>
-                      <a:headEnd type="none" w="med" len="med"/>
-                      <a:tailEnd type="none" w="med" len="med"/>
-                    </a:lnR>
-                    <a:lnT w="9525" cap="flat" cmpd="sng" algn="ctr">
-                      <a:solidFill>
-                        <a:srgbClr val="E4DFCF"/>
-                      </a:solidFill>
-                      <a:prstDash val="solid"/>
-                      <a:round/>
-                      <a:headEnd type="none" w="med" len="med"/>
-                      <a:tailEnd type="none" w="med" len="med"/>
-                    </a:lnT>
-                    <a:lnB w="9525" cap="flat" cmpd="sng" algn="ctr">
-                      <a:solidFill>
-                        <a:srgbClr val="E4DFCF"/>
-                      </a:solidFill>
-                      <a:prstDash val="solid"/>
-                      <a:round/>
-                      <a:headEnd type="none" w="med" len="med"/>
-                      <a:tailEnd type="none" w="med" len="med"/>
-                    </a:lnB>
-                  </a:tcPr>
-                </a:tc>
-              </a:tr>
             </a:tbl>
           </a:graphicData>
         </a:graphic>
@@ -14167,6 +14168,45 @@
       <p:sp>
         <p:nvSpPr>
           <p:cNvPr id="6" name="Text 3"/>
+          <p:cNvSpPr txBox="1"/>
+          <p:nvPr/>
+        </p:nvSpPr>
+        <p:spPr>
+          <a:xfrm>
+            <a:off x="548640" y="4206240"/>
+            <a:ext cx="5394960" cy="457200"/>
+          </a:xfrm>
+          <a:prstGeom prst="rect">
+            <a:avLst/>
+          </a:prstGeom>
+          <a:noFill/>
+          <a:ln/>
+        </p:spPr>
+        <p:txBody>
+          <a:bodyPr wrap="square" lIns="0" tIns="0" rIns="0" bIns="0" rtlCol="0" anchor="ctr"/>
+          <a:lstStyle/>
+          <a:p>
+            <a:pPr indent="0" marL="0">
+              <a:buNone/>
+            </a:pPr>
+            <a:r>
+              <a:rPr lang="en-US" sz="1000" i="1" dirty="0">
+                <a:solidFill>
+                  <a:srgbClr val="8A876F"/>
+                </a:solidFill>
+                <a:latin typeface="Calibri" pitchFamily="34" charset="0"/>
+                <a:ea typeface="Calibri" pitchFamily="34" charset="-122"/>
+                <a:cs typeface="Calibri" pitchFamily="34" charset="-120"/>
+              </a:rPr>
+              <a:t>Vet fees are billed and paid directly by the owner — a pass-through, not Foundation revenue or cost.</a:t>
+            </a:r>
+            <a:endParaRPr lang="en-US" sz="1000" dirty="0"/>
+          </a:p>
+        </p:txBody>
+      </p:sp>
+      <p:sp>
+        <p:nvSpPr>
+          <p:cNvPr id="7" name="Text 4"/>
           <p:cNvSpPr txBox="1"/>
           <p:nvPr/>
         </p:nvSpPr>
@@ -15033,7 +15073,7 @@
       </p:graphicFrame>
       <p:sp>
         <p:nvSpPr>
-          <p:cNvPr id="8" name="Text 4"/>
+          <p:cNvPr id="9" name="Text 5"/>
           <p:cNvSpPr txBox="1"/>
           <p:nvPr/>
         </p:nvSpPr>
@@ -15174,7 +15214,7 @@
                 <a:ea typeface="Cambria" pitchFamily="34" charset="-122"/>
                 <a:cs typeface="Cambria" pitchFamily="34" charset="-120"/>
               </a:rPr>
-              <a:t>The sanctuary is the differentiator, not price</a:t>
+              <a:t>Retirement boarding fills a real gap — and feeds plot sales</a:t>
             </a:r>
             <a:endParaRPr lang="en-US" sz="3000" dirty="0"/>
           </a:p>
@@ -15216,7 +15256,7 @@
                 <a:ea typeface="Calibri" pitchFamily="34" charset="-122"/>
                 <a:cs typeface="Calibri" pitchFamily="34" charset="-120"/>
               </a:rPr>
-              <a:t>A dedicated equine-therapy + rescue story is distinctive in Thailand's mostly elephant-focused animal-welfare tourism. Thai horse-owning families want land near an established equestrian facility — the sanctuary is the anchor amenity that makes these plots more attractive than raw land.</a:t>
+              <a:t>Thai horse owners have few dedicated, professionally run retirement/wellness boarding options — most livery is geared to active competition horses. A facility built specifically for retirement care is a clear gap, and the therapy program adds a CSR story most boarding stables don't have.</a:t>
             </a:r>
             <a:endParaRPr lang="en-US" sz="1400" dirty="0"/>
           </a:p>
@@ -15266,7 +15306,7 @@
       </p:sp>
       <p:pic>
         <p:nvPicPr>
-          <p:cNvPr id="7" name="Image 0" descr="/tmp/claude-0/-home-user-FarmDeApp/6acb5467-a921-52c6-8401-d505f26136ca/scratchpad/pptx_assets/home.png">    </p:cNvPr>
+          <p:cNvPr id="7" name="Image 0" descr="/tmp/claude-0/-home-user-FarmDeApp/6acb5467-a921-52c6-8401-d505f26136ca/scratchpad/pptx_assets/horse.png">    </p:cNvPr>
           <p:cNvPicPr>
             <a:picLocks noChangeAspect="1"/>
           </p:cNvPicPr>
@@ -15321,7 +15361,7 @@
                 <a:ea typeface="Cambria" pitchFamily="34" charset="-122"/>
                 <a:cs typeface="Cambria" pitchFamily="34" charset="-120"/>
               </a:rPr>
-              <a:t>Horse-owning families</a:t>
+              <a:t>Horse owners needing boarding</a:t>
             </a:r>
             <a:endParaRPr lang="en-US" sz="1300" dirty="0"/>
           </a:p>
@@ -15360,7 +15400,7 @@
                 <a:ea typeface="Calibri" pitchFamily="34" charset="-122"/>
                 <a:cs typeface="Calibri" pitchFamily="34" charset="-120"/>
               </a:rPr>
-              <a:t>Seeking land with shared equestrian infrastructure — the primary near-term transaction</a:t>
+              <a:t>The sanctuary's core paying customer — the primary near-term transaction</a:t>
             </a:r>
             <a:endParaRPr lang="en-US" sz="1050" dirty="0"/>
           </a:p>
@@ -15410,7 +15450,7 @@
       </p:sp>
       <p:pic>
         <p:nvPicPr>
-          <p:cNvPr id="12" name="Image 1" descr="/tmp/claude-0/-home-user-FarmDeApp/6acb5467-a921-52c6-8401-d505f26136ca/scratchpad/pptx_assets/coins.png">    </p:cNvPr>
+          <p:cNvPr id="12" name="Image 1" descr="/tmp/claude-0/-home-user-FarmDeApp/6acb5467-a921-52c6-8401-d505f26136ca/scratchpad/pptx_assets/home.png">    </p:cNvPr>
           <p:cNvPicPr>
             <a:picLocks noChangeAspect="1"/>
           </p:cNvPicPr>
@@ -15465,7 +15505,7 @@
                 <a:ea typeface="Cambria" pitchFamily="34" charset="-122"/>
                 <a:cs typeface="Cambria" pitchFamily="34" charset="-120"/>
               </a:rPr>
-              <a:t>Corporate CSR / grant-makers</a:t>
+              <a:t>Boarding clients as plot buyers</a:t>
             </a:r>
             <a:endParaRPr lang="en-US" sz="1300" dirty="0"/>
           </a:p>
@@ -15504,7 +15544,7 @@
                 <a:ea typeface="Calibri" pitchFamily="34" charset="-122"/>
                 <a:cs typeface="Calibri" pitchFamily="34" charset="-120"/>
               </a:rPr>
-              <a:t>Funding the therapy program</a:t>
+              <a:t>Highest-probability plot-sale lead — treat as the default sales funnel</a:t>
             </a:r>
             <a:endParaRPr lang="en-US" sz="1050" dirty="0"/>
           </a:p>
@@ -15554,7 +15594,7 @@
       </p:sp>
       <p:pic>
         <p:nvPicPr>
-          <p:cNvPr id="17" name="Image 2" descr="/tmp/claude-0/-home-user-FarmDeApp/6acb5467-a921-52c6-8401-d505f26136ca/scratchpad/pptx_assets/child.png">    </p:cNvPr>
+          <p:cNvPr id="17" name="Image 2" descr="/tmp/claude-0/-home-user-FarmDeApp/6acb5467-a921-52c6-8401-d505f26136ca/scratchpad/pptx_assets/coins.png">    </p:cNvPr>
           <p:cNvPicPr>
             <a:picLocks noChangeAspect="1"/>
           </p:cNvPicPr>
@@ -15609,7 +15649,7 @@
                 <a:ea typeface="Cambria" pitchFamily="34" charset="-122"/>
                 <a:cs typeface="Cambria" pitchFamily="34" charset="-120"/>
               </a:rPr>
-              <a:t>Schools &amp; hospitals</a:t>
+              <a:t>Corporate CSR / grant-makers</a:t>
             </a:r>
             <a:endParaRPr lang="en-US" sz="1300" dirty="0"/>
           </a:p>
@@ -15648,7 +15688,7 @@
                 <a:ea typeface="Calibri" pitchFamily="34" charset="-122"/>
                 <a:cs typeface="Calibri" pitchFamily="34" charset="-120"/>
               </a:rPr>
-              <a:t>Referring families for equine-assisted therapy</a:t>
+              <a:t>Funding the therapy program</a:t>
             </a:r>
             <a:endParaRPr lang="en-US" sz="1050" dirty="0"/>
           </a:p>
@@ -15698,7 +15738,7 @@
       </p:sp>
       <p:pic>
         <p:nvPicPr>
-          <p:cNvPr id="22" name="Image 3" descr="/tmp/claude-0/-home-user-FarmDeApp/6acb5467-a921-52c6-8401-d505f26136ca/scratchpad/pptx_assets/heart.png">    </p:cNvPr>
+          <p:cNvPr id="22" name="Image 3" descr="/tmp/claude-0/-home-user-FarmDeApp/6acb5467-a921-52c6-8401-d505f26136ca/scratchpad/pptx_assets/child.png">    </p:cNvPr>
           <p:cNvPicPr>
             <a:picLocks noChangeAspect="1"/>
           </p:cNvPicPr>
@@ -15753,7 +15793,7 @@
                 <a:ea typeface="Cambria" pitchFamily="34" charset="-122"/>
                 <a:cs typeface="Cambria" pitchFamily="34" charset="-120"/>
               </a:rPr>
-              <a:t>Existing Foundation donors</a:t>
+              <a:t>Schools &amp; hospitals</a:t>
             </a:r>
             <a:endParaRPr lang="en-US" sz="1300" dirty="0"/>
           </a:p>
@@ -15792,7 +15832,7 @@
                 <a:ea typeface="Calibri" pitchFamily="34" charset="-122"/>
                 <a:cs typeface="Calibri" pitchFamily="34" charset="-120"/>
               </a:rPr>
-              <a:t>Natural audience for horse sponsorship</a:t>
+              <a:t>Referring families for equine-assisted therapy</a:t>
             </a:r>
             <a:endParaRPr lang="en-US" sz="1050" dirty="0"/>
           </a:p>

</xml_diff>